<commit_message>
Update IoTeye - Arc Mercer Pitch.pptx
</commit_message>
<xml_diff>
--- a/RFP/IoTeye - Arc Mercer Pitch.pptx
+++ b/RFP/IoTeye - Arc Mercer Pitch.pptx
@@ -22,6 +22,7 @@
     <p:sldId id="270" r:id="rId16"/>
     <p:sldId id="271" r:id="rId17"/>
     <p:sldId id="272" r:id="rId18"/>
+    <p:sldId id="273" r:id="rId19"/>
   </p:sldIdLst>
   <p:sldSz cx="12192000" cy="6858000"/>
   <p:notesSz cx="6858000" cy="9144000"/>
@@ -318,7 +319,7 @@
           <a:p>
             <a:fld id="{5BCAD085-E8A6-8845-BD4E-CB4CCA059FC4}" type="datetimeFigureOut">
               <a:rPr lang="en-US" smtClean="0"/>
-              <a:t>4/17/2026</a:t>
+              <a:t>9/22/2026</a:t>
             </a:fld>
             <a:endParaRPr lang="en-US"/>
           </a:p>
@@ -486,7 +487,7 @@
           <a:p>
             <a:fld id="{5BCAD085-E8A6-8845-BD4E-CB4CCA059FC4}" type="datetimeFigureOut">
               <a:rPr lang="en-US" smtClean="0"/>
-              <a:t>4/17/2026</a:t>
+              <a:t>9/22/2026</a:t>
             </a:fld>
             <a:endParaRPr lang="en-US"/>
           </a:p>
@@ -664,7 +665,7 @@
           <a:p>
             <a:fld id="{5BCAD085-E8A6-8845-BD4E-CB4CCA059FC4}" type="datetimeFigureOut">
               <a:rPr lang="en-US" smtClean="0"/>
-              <a:t>4/17/2026</a:t>
+              <a:t>9/22/2026</a:t>
             </a:fld>
             <a:endParaRPr lang="en-US"/>
           </a:p>
@@ -832,7 +833,7 @@
           <a:p>
             <a:fld id="{5BCAD085-E8A6-8845-BD4E-CB4CCA059FC4}" type="datetimeFigureOut">
               <a:rPr lang="en-US" smtClean="0"/>
-              <a:t>4/17/2026</a:t>
+              <a:t>9/22/2026</a:t>
             </a:fld>
             <a:endParaRPr lang="en-US"/>
           </a:p>
@@ -1077,7 +1078,7 @@
           <a:p>
             <a:fld id="{5BCAD085-E8A6-8845-BD4E-CB4CCA059FC4}" type="datetimeFigureOut">
               <a:rPr lang="en-US" smtClean="0"/>
-              <a:t>4/17/2026</a:t>
+              <a:t>9/22/2026</a:t>
             </a:fld>
             <a:endParaRPr lang="en-US"/>
           </a:p>
@@ -1362,7 +1363,7 @@
           <a:p>
             <a:fld id="{5BCAD085-E8A6-8845-BD4E-CB4CCA059FC4}" type="datetimeFigureOut">
               <a:rPr lang="en-US" smtClean="0"/>
-              <a:t>4/17/2026</a:t>
+              <a:t>9/22/2026</a:t>
             </a:fld>
             <a:endParaRPr lang="en-US"/>
           </a:p>
@@ -1781,7 +1782,7 @@
           <a:p>
             <a:fld id="{5BCAD085-E8A6-8845-BD4E-CB4CCA059FC4}" type="datetimeFigureOut">
               <a:rPr lang="en-US" smtClean="0"/>
-              <a:t>4/17/2026</a:t>
+              <a:t>9/22/2026</a:t>
             </a:fld>
             <a:endParaRPr lang="en-US"/>
           </a:p>
@@ -1898,7 +1899,7 @@
           <a:p>
             <a:fld id="{5BCAD085-E8A6-8845-BD4E-CB4CCA059FC4}" type="datetimeFigureOut">
               <a:rPr lang="en-US" smtClean="0"/>
-              <a:t>4/17/2026</a:t>
+              <a:t>9/22/2026</a:t>
             </a:fld>
             <a:endParaRPr lang="en-US"/>
           </a:p>
@@ -1993,7 +1994,7 @@
           <a:p>
             <a:fld id="{5BCAD085-E8A6-8845-BD4E-CB4CCA059FC4}" type="datetimeFigureOut">
               <a:rPr lang="en-US" smtClean="0"/>
-              <a:t>4/17/2026</a:t>
+              <a:t>9/22/2026</a:t>
             </a:fld>
             <a:endParaRPr lang="en-US"/>
           </a:p>
@@ -2268,7 +2269,7 @@
           <a:p>
             <a:fld id="{5BCAD085-E8A6-8845-BD4E-CB4CCA059FC4}" type="datetimeFigureOut">
               <a:rPr lang="en-US" smtClean="0"/>
-              <a:t>4/17/2026</a:t>
+              <a:t>9/22/2026</a:t>
             </a:fld>
             <a:endParaRPr lang="en-US"/>
           </a:p>
@@ -2520,7 +2521,7 @@
           <a:p>
             <a:fld id="{5BCAD085-E8A6-8845-BD4E-CB4CCA059FC4}" type="datetimeFigureOut">
               <a:rPr lang="en-US" smtClean="0"/>
-              <a:t>4/17/2026</a:t>
+              <a:t>9/22/2026</a:t>
             </a:fld>
             <a:endParaRPr lang="en-US"/>
           </a:p>
@@ -2731,7 +2732,7 @@
           <a:p>
             <a:fld id="{5BCAD085-E8A6-8845-BD4E-CB4CCA059FC4}" type="datetimeFigureOut">
               <a:rPr lang="en-US" smtClean="0"/>
-              <a:t>4/17/2026</a:t>
+              <a:t>9/22/2026</a:t>
             </a:fld>
             <a:endParaRPr lang="en-US"/>
           </a:p>
@@ -14033,6 +14034,673 @@
         </p:txBody>
       </p:sp>
     </p:spTree>
+  </p:cSld>
+  <p:clrMapOvr>
+    <a:masterClrMapping/>
+  </p:clrMapOvr>
+</p:sld>
+</file>
+
+<file path=ppt/slides/slide18.xml><?xml version="1.0" encoding="utf-8"?>
+<p:sld xmlns:a="http://schemas.openxmlformats.org/drawingml/2006/main" xmlns:r="http://schemas.openxmlformats.org/officeDocument/2006/relationships" xmlns:p="http://schemas.openxmlformats.org/presentationml/2006/main">
+  <p:cSld>
+    <p:spTree>
+      <p:nvGrpSpPr>
+        <p:cNvPr id="1" name="">
+          <a:extLst>
+            <a:ext uri="{FF2B5EF4-FFF2-40B4-BE49-F238E27FC236}">
+              <a16:creationId xmlns:a16="http://schemas.microsoft.com/office/drawing/2014/main" id="{B74ED218-7648-A835-BF1D-5E94332CA0A4}"/>
+            </a:ext>
+          </a:extLst>
+        </p:cNvPr>
+        <p:cNvGrpSpPr/>
+        <p:nvPr/>
+      </p:nvGrpSpPr>
+      <p:grpSpPr>
+        <a:xfrm>
+          <a:off x="0" y="0"/>
+          <a:ext cx="0" cy="0"/>
+          <a:chOff x="0" y="0"/>
+          <a:chExt cx="0" cy="0"/>
+        </a:xfrm>
+      </p:grpSpPr>
+      <p:sp>
+        <p:nvSpPr>
+          <p:cNvPr id="2" name="Rectangle 1">
+            <a:extLst>
+              <a:ext uri="{FF2B5EF4-FFF2-40B4-BE49-F238E27FC236}">
+                <a16:creationId xmlns:a16="http://schemas.microsoft.com/office/drawing/2014/main" id="{A72F36C0-0597-3777-2AF0-0028740E26BA}"/>
+              </a:ext>
+            </a:extLst>
+          </p:cNvPr>
+          <p:cNvSpPr/>
+          <p:nvPr/>
+        </p:nvSpPr>
+        <p:spPr>
+          <a:xfrm>
+            <a:off x="0" y="0"/>
+            <a:ext cx="12191695" cy="1005840"/>
+          </a:xfrm>
+          <a:prstGeom prst="rect">
+            <a:avLst/>
+          </a:prstGeom>
+          <a:solidFill>
+            <a:srgbClr val="1B2A4A"/>
+          </a:solidFill>
+          <a:ln>
+            <a:noFill/>
+          </a:ln>
+        </p:spPr>
+        <p:style>
+          <a:lnRef idx="1">
+            <a:schemeClr val="accent1"/>
+          </a:lnRef>
+          <a:fillRef idx="3">
+            <a:schemeClr val="accent1"/>
+          </a:fillRef>
+          <a:effectRef idx="2">
+            <a:schemeClr val="accent1"/>
+          </a:effectRef>
+          <a:fontRef idx="minor">
+            <a:schemeClr val="lt1"/>
+          </a:fontRef>
+        </p:style>
+        <p:txBody>
+          <a:bodyPr rtlCol="0" anchor="ctr"/>
+          <a:lstStyle/>
+          <a:p>
+            <a:pPr algn="ctr"/>
+            <a:endParaRPr/>
+          </a:p>
+        </p:txBody>
+      </p:sp>
+      <p:sp>
+        <p:nvSpPr>
+          <p:cNvPr id="3" name="TextBox 2">
+            <a:extLst>
+              <a:ext uri="{FF2B5EF4-FFF2-40B4-BE49-F238E27FC236}">
+                <a16:creationId xmlns:a16="http://schemas.microsoft.com/office/drawing/2014/main" id="{343F4B28-8A63-B57C-9E98-3BCF999B28C2}"/>
+              </a:ext>
+            </a:extLst>
+          </p:cNvPr>
+          <p:cNvSpPr txBox="1"/>
+          <p:nvPr/>
+        </p:nvSpPr>
+        <p:spPr>
+          <a:xfrm>
+            <a:off x="731520" y="182880"/>
+            <a:ext cx="10058400" cy="584775"/>
+          </a:xfrm>
+          <a:prstGeom prst="rect">
+            <a:avLst/>
+          </a:prstGeom>
+          <a:noFill/>
+        </p:spPr>
+        <p:txBody>
+          <a:bodyPr wrap="square">
+            <a:spAutoFit/>
+          </a:bodyPr>
+          <a:lstStyle/>
+          <a:p>
+            <a:pPr algn="l">
+              <a:defRPr sz="3200" b="1">
+                <a:solidFill>
+                  <a:srgbClr val="FFFFFF"/>
+                </a:solidFill>
+                <a:latin typeface="Calibri"/>
+              </a:defRPr>
+            </a:pPr>
+            <a:r>
+              <a:rPr dirty="0"/>
+              <a:t>Next Steps</a:t>
+            </a:r>
+          </a:p>
+        </p:txBody>
+      </p:sp>
+      <p:sp>
+        <p:nvSpPr>
+          <p:cNvPr id="4" name="TextBox 3">
+            <a:extLst>
+              <a:ext uri="{FF2B5EF4-FFF2-40B4-BE49-F238E27FC236}">
+                <a16:creationId xmlns:a16="http://schemas.microsoft.com/office/drawing/2014/main" id="{3EBE8F14-C83E-A845-B8CF-91DEB6D0AF6B}"/>
+              </a:ext>
+            </a:extLst>
+          </p:cNvPr>
+          <p:cNvSpPr txBox="1"/>
+          <p:nvPr/>
+        </p:nvSpPr>
+        <p:spPr>
+          <a:xfrm>
+            <a:off x="731520" y="1188720"/>
+            <a:ext cx="5029200" cy="457200"/>
+          </a:xfrm>
+          <a:prstGeom prst="rect">
+            <a:avLst/>
+          </a:prstGeom>
+          <a:noFill/>
+        </p:spPr>
+        <p:txBody>
+          <a:bodyPr wrap="square">
+            <a:spAutoFit/>
+          </a:bodyPr>
+          <a:lstStyle/>
+          <a:p>
+            <a:pPr algn="l">
+              <a:defRPr sz="2400" b="1">
+                <a:solidFill>
+                  <a:srgbClr val="2E86C1"/>
+                </a:solidFill>
+                <a:latin typeface="Calibri"/>
+              </a:defRPr>
+            </a:pPr>
+            <a:r>
+              <a:t>Why We're the Right Partner</a:t>
+            </a:r>
+          </a:p>
+        </p:txBody>
+      </p:sp>
+      <p:sp>
+        <p:nvSpPr>
+          <p:cNvPr id="5" name="TextBox 4">
+            <a:extLst>
+              <a:ext uri="{FF2B5EF4-FFF2-40B4-BE49-F238E27FC236}">
+                <a16:creationId xmlns:a16="http://schemas.microsoft.com/office/drawing/2014/main" id="{E405D3F8-0D85-DAB5-503F-51E8CACEEDFB}"/>
+              </a:ext>
+            </a:extLst>
+          </p:cNvPr>
+          <p:cNvSpPr txBox="1"/>
+          <p:nvPr/>
+        </p:nvSpPr>
+        <p:spPr>
+          <a:xfrm>
+            <a:off x="731520" y="1737360"/>
+            <a:ext cx="5029200" cy="2672526"/>
+          </a:xfrm>
+          <a:prstGeom prst="rect">
+            <a:avLst/>
+          </a:prstGeom>
+          <a:noFill/>
+        </p:spPr>
+        <p:txBody>
+          <a:bodyPr wrap="square">
+            <a:spAutoFit/>
+          </a:bodyPr>
+          <a:lstStyle/>
+          <a:p>
+            <a:pPr algn="l">
+              <a:spcAft>
+                <a:spcPts val="1000"/>
+              </a:spcAft>
+              <a:defRPr sz="1400" b="0">
+                <a:solidFill>
+                  <a:srgbClr val="333333"/>
+                </a:solidFill>
+                <a:latin typeface="Calibri"/>
+              </a:defRPr>
+            </a:pPr>
+            <a:r>
+              <a:rPr dirty="0"/>
+              <a:t>• </a:t>
+            </a:r>
+            <a:r>
+              <a:rPr lang="en-US" dirty="0"/>
+              <a:t>6</a:t>
+            </a:r>
+            <a:r>
+              <a:rPr dirty="0"/>
+              <a:t>+ years in special care software — we know your workforce</a:t>
+            </a:r>
+          </a:p>
+          <a:p>
+            <a:pPr>
+              <a:spcAft>
+                <a:spcPts val="1000"/>
+              </a:spcAft>
+              <a:defRPr sz="1400">
+                <a:solidFill>
+                  <a:srgbClr val="333333"/>
+                </a:solidFill>
+                <a:latin typeface="Calibri"/>
+              </a:defRPr>
+            </a:pPr>
+            <a:r>
+              <a:rPr dirty="0"/>
+              <a:t>• Arc Mercer is an existing </a:t>
+            </a:r>
+            <a:r>
+              <a:rPr dirty="0" err="1"/>
+              <a:t>IoTeye</a:t>
+            </a:r>
+            <a:r>
+              <a:rPr dirty="0"/>
+              <a:t> customer (</a:t>
+            </a:r>
+            <a:r>
+              <a:rPr dirty="0" err="1"/>
+              <a:t>SpringBoard</a:t>
+            </a:r>
+            <a:r>
+              <a:rPr dirty="0"/>
+              <a:t> &amp; Guardian)</a:t>
+            </a:r>
+          </a:p>
+          <a:p>
+            <a:pPr>
+              <a:spcAft>
+                <a:spcPts val="1000"/>
+              </a:spcAft>
+              <a:defRPr sz="1400">
+                <a:solidFill>
+                  <a:srgbClr val="333333"/>
+                </a:solidFill>
+                <a:latin typeface="Calibri"/>
+              </a:defRPr>
+            </a:pPr>
+            <a:r>
+              <a:rPr dirty="0"/>
+              <a:t>• Brain</a:t>
+            </a:r>
+            <a:r>
+              <a:rPr lang="en-US" dirty="0"/>
+              <a:t>Book</a:t>
+            </a:r>
+            <a:r>
+              <a:rPr dirty="0"/>
+              <a:t> AI agents already in </a:t>
+            </a:r>
+            <a:r>
+              <a:rPr lang="en-US" dirty="0"/>
+              <a:t>trials</a:t>
+            </a:r>
+            <a:r>
+              <a:rPr dirty="0"/>
+              <a:t> at Arc Mercer (37+57 tools)</a:t>
+            </a:r>
+          </a:p>
+          <a:p>
+            <a:pPr>
+              <a:spcAft>
+                <a:spcPts val="1000"/>
+              </a:spcAft>
+              <a:defRPr sz="1400">
+                <a:solidFill>
+                  <a:srgbClr val="333333"/>
+                </a:solidFill>
+                <a:latin typeface="Calibri"/>
+              </a:defRPr>
+            </a:pPr>
+            <a:r>
+              <a:rPr dirty="0"/>
+              <a:t>• In-house Paycom </a:t>
+            </a:r>
+            <a:r>
+              <a:rPr lang="en-US" dirty="0"/>
+              <a:t>&amp; Springboard </a:t>
+            </a:r>
+            <a:r>
+              <a:rPr dirty="0"/>
+              <a:t>&amp; Guardian integration experience at Arc Mercer, not a cold start</a:t>
+            </a:r>
+          </a:p>
+          <a:p>
+            <a:pPr>
+              <a:spcAft>
+                <a:spcPts val="1000"/>
+              </a:spcAft>
+              <a:defRPr sz="1400">
+                <a:solidFill>
+                  <a:srgbClr val="333333"/>
+                </a:solidFill>
+                <a:latin typeface="Calibri"/>
+              </a:defRPr>
+            </a:pPr>
+            <a:r>
+              <a:rPr dirty="0"/>
+              <a:t>• </a:t>
+            </a:r>
+            <a:r>
+              <a:rPr lang="en-US" dirty="0"/>
+              <a:t>Shared Ownership on </a:t>
+            </a:r>
+            <a:r>
+              <a:rPr lang="en-US"/>
+              <a:t>IP</a:t>
+            </a:r>
+            <a:r>
+              <a:t> </a:t>
+            </a:r>
+            <a:r>
+              <a:rPr lang="en-US"/>
+              <a:t>and Monthly Maintenance </a:t>
+            </a:r>
+            <a:r>
+              <a:rPr lang="en-US" dirty="0"/>
+              <a:t>C</a:t>
+            </a:r>
+            <a:r>
+              <a:rPr lang="en-US"/>
+              <a:t>ost</a:t>
+            </a:r>
+            <a:endParaRPr dirty="0"/>
+          </a:p>
+          <a:p>
+            <a:pPr>
+              <a:spcAft>
+                <a:spcPts val="1000"/>
+              </a:spcAft>
+              <a:defRPr sz="1400">
+                <a:solidFill>
+                  <a:srgbClr val="333333"/>
+                </a:solidFill>
+                <a:latin typeface="Calibri"/>
+              </a:defRPr>
+            </a:pPr>
+            <a:r>
+              <a:rPr dirty="0"/>
+              <a:t>• AI-assisted add-ons FREE — pay only AI LLM usage (pass-through)</a:t>
+            </a:r>
+          </a:p>
+        </p:txBody>
+      </p:sp>
+      <p:sp>
+        <p:nvSpPr>
+          <p:cNvPr id="6" name="TextBox 5">
+            <a:extLst>
+              <a:ext uri="{FF2B5EF4-FFF2-40B4-BE49-F238E27FC236}">
+                <a16:creationId xmlns:a16="http://schemas.microsoft.com/office/drawing/2014/main" id="{882BD282-C2C4-26C8-A4F8-36A9C4C9075A}"/>
+              </a:ext>
+            </a:extLst>
+          </p:cNvPr>
+          <p:cNvSpPr txBox="1"/>
+          <p:nvPr/>
+        </p:nvSpPr>
+        <p:spPr>
+          <a:xfrm>
+            <a:off x="6400800" y="1188720"/>
+            <a:ext cx="5029200" cy="457200"/>
+          </a:xfrm>
+          <a:prstGeom prst="rect">
+            <a:avLst/>
+          </a:prstGeom>
+          <a:noFill/>
+        </p:spPr>
+        <p:txBody>
+          <a:bodyPr wrap="square">
+            <a:spAutoFit/>
+          </a:bodyPr>
+          <a:lstStyle/>
+          <a:p>
+            <a:pPr algn="l">
+              <a:defRPr sz="2400" b="1">
+                <a:solidFill>
+                  <a:srgbClr val="2E86C1"/>
+                </a:solidFill>
+                <a:latin typeface="Calibri"/>
+              </a:defRPr>
+            </a:pPr>
+            <a:r>
+              <a:t>Next Steps</a:t>
+            </a:r>
+          </a:p>
+        </p:txBody>
+      </p:sp>
+      <p:sp>
+        <p:nvSpPr>
+          <p:cNvPr id="7" name="TextBox 6">
+            <a:extLst>
+              <a:ext uri="{FF2B5EF4-FFF2-40B4-BE49-F238E27FC236}">
+                <a16:creationId xmlns:a16="http://schemas.microsoft.com/office/drawing/2014/main" id="{90A6C9A3-CE73-6DEE-F1E0-13521823EDEC}"/>
+              </a:ext>
+            </a:extLst>
+          </p:cNvPr>
+          <p:cNvSpPr txBox="1"/>
+          <p:nvPr/>
+        </p:nvSpPr>
+        <p:spPr>
+          <a:xfrm>
+            <a:off x="6400800" y="2008108"/>
+            <a:ext cx="5029200" cy="738664"/>
+          </a:xfrm>
+          <a:prstGeom prst="rect">
+            <a:avLst/>
+          </a:prstGeom>
+          <a:noFill/>
+        </p:spPr>
+        <p:txBody>
+          <a:bodyPr wrap="square">
+            <a:spAutoFit/>
+          </a:bodyPr>
+          <a:lstStyle/>
+          <a:p>
+            <a:pPr algn="l">
+              <a:spcAft>
+                <a:spcPts val="1200"/>
+              </a:spcAft>
+              <a:defRPr sz="1600" b="0">
+                <a:solidFill>
+                  <a:srgbClr val="333333"/>
+                </a:solidFill>
+                <a:latin typeface="Calibri"/>
+              </a:defRPr>
+            </a:pPr>
+            <a:r>
+              <a:rPr dirty="0"/>
+              <a:t>• Schedule kickoff &amp; discovery workshop</a:t>
+            </a:r>
+          </a:p>
+          <a:p>
+            <a:pPr>
+              <a:spcAft>
+                <a:spcPts val="1200"/>
+              </a:spcAft>
+              <a:defRPr sz="1600">
+                <a:solidFill>
+                  <a:srgbClr val="333333"/>
+                </a:solidFill>
+                <a:latin typeface="Calibri"/>
+              </a:defRPr>
+            </a:pPr>
+            <a:r>
+              <a:rPr dirty="0"/>
+              <a:t>• Phase One live in 12 weeks</a:t>
+            </a:r>
+          </a:p>
+        </p:txBody>
+      </p:sp>
+      <p:sp>
+        <p:nvSpPr>
+          <p:cNvPr id="8" name="Rectangle 7">
+            <a:extLst>
+              <a:ext uri="{FF2B5EF4-FFF2-40B4-BE49-F238E27FC236}">
+                <a16:creationId xmlns:a16="http://schemas.microsoft.com/office/drawing/2014/main" id="{56A045E5-2D8F-DE52-0C4B-F37900BF1FAE}"/>
+              </a:ext>
+            </a:extLst>
+          </p:cNvPr>
+          <p:cNvSpPr/>
+          <p:nvPr/>
+        </p:nvSpPr>
+        <p:spPr>
+          <a:xfrm>
+            <a:off x="6400800" y="4389120"/>
+            <a:ext cx="4572000" cy="1828800"/>
+          </a:xfrm>
+          <a:prstGeom prst="rect">
+            <a:avLst/>
+          </a:prstGeom>
+          <a:solidFill>
+            <a:srgbClr val="D6EAF8"/>
+          </a:solidFill>
+          <a:ln>
+            <a:noFill/>
+          </a:ln>
+        </p:spPr>
+        <p:style>
+          <a:lnRef idx="1">
+            <a:schemeClr val="accent1"/>
+          </a:lnRef>
+          <a:fillRef idx="3">
+            <a:schemeClr val="accent1"/>
+          </a:fillRef>
+          <a:effectRef idx="2">
+            <a:schemeClr val="accent1"/>
+          </a:effectRef>
+          <a:fontRef idx="minor">
+            <a:schemeClr val="lt1"/>
+          </a:fontRef>
+        </p:style>
+        <p:txBody>
+          <a:bodyPr rtlCol="0" anchor="ctr"/>
+          <a:lstStyle/>
+          <a:p>
+            <a:pPr algn="ctr"/>
+            <a:endParaRPr/>
+          </a:p>
+        </p:txBody>
+      </p:sp>
+      <p:sp>
+        <p:nvSpPr>
+          <p:cNvPr id="9" name="TextBox 8">
+            <a:extLst>
+              <a:ext uri="{FF2B5EF4-FFF2-40B4-BE49-F238E27FC236}">
+                <a16:creationId xmlns:a16="http://schemas.microsoft.com/office/drawing/2014/main" id="{A60F0BDC-64D5-BC28-103D-DEBB404DCD33}"/>
+              </a:ext>
+            </a:extLst>
+          </p:cNvPr>
+          <p:cNvSpPr txBox="1"/>
+          <p:nvPr/>
+        </p:nvSpPr>
+        <p:spPr>
+          <a:xfrm>
+            <a:off x="6675120" y="4480560"/>
+            <a:ext cx="4114800" cy="457200"/>
+          </a:xfrm>
+          <a:prstGeom prst="rect">
+            <a:avLst/>
+          </a:prstGeom>
+          <a:noFill/>
+        </p:spPr>
+        <p:txBody>
+          <a:bodyPr wrap="square">
+            <a:spAutoFit/>
+          </a:bodyPr>
+          <a:lstStyle/>
+          <a:p>
+            <a:pPr algn="l">
+              <a:defRPr sz="2200" b="1">
+                <a:solidFill>
+                  <a:srgbClr val="1B2A4A"/>
+                </a:solidFill>
+                <a:latin typeface="Calibri"/>
+              </a:defRPr>
+            </a:pPr>
+            <a:r>
+              <a:t>Contact Us</a:t>
+            </a:r>
+          </a:p>
+        </p:txBody>
+      </p:sp>
+      <p:sp>
+        <p:nvSpPr>
+          <p:cNvPr id="10" name="TextBox 9">
+            <a:extLst>
+              <a:ext uri="{FF2B5EF4-FFF2-40B4-BE49-F238E27FC236}">
+                <a16:creationId xmlns:a16="http://schemas.microsoft.com/office/drawing/2014/main" id="{99203A22-0CF7-9A41-CC19-5FBCB4C54FF2}"/>
+              </a:ext>
+            </a:extLst>
+          </p:cNvPr>
+          <p:cNvSpPr txBox="1"/>
+          <p:nvPr/>
+        </p:nvSpPr>
+        <p:spPr>
+          <a:xfrm>
+            <a:off x="6675120" y="4937760"/>
+            <a:ext cx="4114800" cy="1097280"/>
+          </a:xfrm>
+          <a:prstGeom prst="rect">
+            <a:avLst/>
+          </a:prstGeom>
+          <a:noFill/>
+        </p:spPr>
+        <p:txBody>
+          <a:bodyPr wrap="square">
+            <a:spAutoFit/>
+          </a:bodyPr>
+          <a:lstStyle/>
+          <a:p>
+            <a:pPr algn="l">
+              <a:defRPr sz="1600" b="0">
+                <a:solidFill>
+                  <a:srgbClr val="333333"/>
+                </a:solidFill>
+                <a:latin typeface="Calibri"/>
+              </a:defRPr>
+            </a:pPr>
+            <a:r>
+              <a:t>IoTeye Inc.</a:t>
+            </a:r>
+            <a:br/>
+            <a:r>
+              <a:t>Basking Ridge, New Jersey</a:t>
+            </a:r>
+            <a:br/>
+            <a:r>
+              <a:t>mingjye.sheng@ioteyeinc.com</a:t>
+            </a:r>
+            <a:br/>
+            <a:r>
+              <a:t>www.ioteyeinc.com</a:t>
+            </a:r>
+          </a:p>
+        </p:txBody>
+      </p:sp>
+      <p:sp>
+        <p:nvSpPr>
+          <p:cNvPr id="11" name="TextBox 10">
+            <a:extLst>
+              <a:ext uri="{FF2B5EF4-FFF2-40B4-BE49-F238E27FC236}">
+                <a16:creationId xmlns:a16="http://schemas.microsoft.com/office/drawing/2014/main" id="{1FBA4DD3-1919-28F7-B55B-BC9AA6868C60}"/>
+              </a:ext>
+            </a:extLst>
+          </p:cNvPr>
+          <p:cNvSpPr txBox="1"/>
+          <p:nvPr/>
+        </p:nvSpPr>
+        <p:spPr>
+          <a:xfrm>
+            <a:off x="731520" y="5669280"/>
+            <a:ext cx="4572000" cy="731520"/>
+          </a:xfrm>
+          <a:prstGeom prst="rect">
+            <a:avLst/>
+          </a:prstGeom>
+          <a:noFill/>
+        </p:spPr>
+        <p:txBody>
+          <a:bodyPr wrap="square">
+            <a:spAutoFit/>
+          </a:bodyPr>
+          <a:lstStyle/>
+          <a:p>
+            <a:pPr algn="l">
+              <a:defRPr sz="4000" b="1">
+                <a:solidFill>
+                  <a:srgbClr val="2E86C1"/>
+                </a:solidFill>
+                <a:latin typeface="Calibri"/>
+              </a:defRPr>
+            </a:pPr>
+            <a:r>
+              <a:t>Thank You</a:t>
+            </a:r>
+          </a:p>
+        </p:txBody>
+      </p:sp>
+    </p:spTree>
+    <p:extLst>
+      <p:ext uri="{BB962C8B-B14F-4D97-AF65-F5344CB8AC3E}">
+        <p14:creationId xmlns:p14="http://schemas.microsoft.com/office/powerpoint/2010/main" val="1930472741"/>
+      </p:ext>
+    </p:extLst>
   </p:cSld>
   <p:clrMapOvr>
     <a:masterClrMapping/>

</xml_diff>